<commit_message>
moved ase2026 slides, added link for plsa
</commit_message>
<xml_diff>
--- a/bibliography/ASE2026 Katenkamp.pptx
+++ b/bibliography/ASE2026 Katenkamp.pptx
@@ -144,25 +144,17 @@
 </p:presentation>
 </file>
 
-<file path=ppt/revisionInfo.xml><?xml version="1.0" encoding="utf-8"?>
-<p1510:revInfo xmlns:a="http://schemas.openxmlformats.org/drawingml/2006/main" xmlns:r="http://schemas.openxmlformats.org/officeDocument/2006/relationships" xmlns:p1510="http://schemas.microsoft.com/office/powerpoint/2015/10/main">
-  <p1510:revLst>
-    <p1510:client id="{2B3D4A8A-6B35-41B7-9E6D-7FD5C0F5ED81}" v="1125" dt="2026-10-08T14:32:04.099"/>
-  </p1510:revLst>
-</p1510:revInfo>
-</file>
-
 <file path=ppt/changesInfos/changesInfo1.xml><?xml version="1.0" encoding="utf-8"?>
 <pc:chgInfo xmlns:a="http://schemas.openxmlformats.org/drawingml/2006/main" xmlns:r="http://schemas.openxmlformats.org/officeDocument/2006/relationships" xmlns:ac="http://schemas.microsoft.com/office/drawing/2013/main/command" xmlns:pc="http://schemas.microsoft.com/office/powerpoint/2013/main/command">
   <pc:docChgLst>
     <pc:chgData name="Katenkamp, Dani" userId="3c420122-3701-45c6-afcd-a2335153bc7c" providerId="ADAL" clId="{C625B387-BACC-4CDF-8090-556983D2B216}"/>
     <pc:docChg chg="undo custSel addSld delSld modSld sldOrd">
-      <pc:chgData name="Katenkamp, Dani" userId="3c420122-3701-45c6-afcd-a2335153bc7c" providerId="ADAL" clId="{C625B387-BACC-4CDF-8090-556983D2B216}" dt="2026-10-08T14:33:54.186" v="18775" actId="1037"/>
+      <pc:chgData name="Katenkamp, Dani" userId="3c420122-3701-45c6-afcd-a2335153bc7c" providerId="ADAL" clId="{C625B387-BACC-4CDF-8090-556983D2B216}" dt="2026-10-16T19:22:41.641" v="18778" actId="478"/>
       <pc:docMkLst>
         <pc:docMk/>
       </pc:docMkLst>
       <pc:sldChg chg="addSp delSp modSp mod setBg">
-        <pc:chgData name="Katenkamp, Dani" userId="3c420122-3701-45c6-afcd-a2335153bc7c" providerId="ADAL" clId="{C625B387-BACC-4CDF-8090-556983D2B216}" dt="2026-10-08T14:33:54.186" v="18775" actId="1037"/>
+        <pc:chgData name="Katenkamp, Dani" userId="3c420122-3701-45c6-afcd-a2335153bc7c" providerId="ADAL" clId="{C625B387-BACC-4CDF-8090-556983D2B216}" dt="2026-10-16T19:22:41.641" v="18778" actId="478"/>
         <pc:sldMkLst>
           <pc:docMk/>
           <pc:sldMk cId="2528761859" sldId="256"/>
@@ -184,47 +176,23 @@
           </ac:spMkLst>
         </pc:spChg>
         <pc:spChg chg="add del mod">
-          <ac:chgData name="Katenkamp, Dani" userId="3c420122-3701-45c6-afcd-a2335153bc7c" providerId="ADAL" clId="{C625B387-BACC-4CDF-8090-556983D2B216}" dt="2026-10-08T14:15:27.169" v="18558" actId="478"/>
-          <ac:spMkLst>
-            <pc:docMk/>
-            <pc:sldMk cId="2528761859" sldId="256"/>
-            <ac:spMk id="4" creationId="{971F156E-C297-F95D-1517-9BF64BF3D8D3}"/>
-          </ac:spMkLst>
-        </pc:spChg>
-        <pc:spChg chg="add del mod">
-          <ac:chgData name="Katenkamp, Dani" userId="3c420122-3701-45c6-afcd-a2335153bc7c" providerId="ADAL" clId="{C625B387-BACC-4CDF-8090-556983D2B216}" dt="2026-10-08T14:25:58.944" v="18591" actId="478"/>
-          <ac:spMkLst>
-            <pc:docMk/>
-            <pc:sldMk cId="2528761859" sldId="256"/>
-            <ac:spMk id="5" creationId="{61C8E3AA-4AC6-D308-58D1-350F4D41EB80}"/>
-          </ac:spMkLst>
-        </pc:spChg>
-        <pc:spChg chg="add del mod">
-          <ac:chgData name="Katenkamp, Dani" userId="3c420122-3701-45c6-afcd-a2335153bc7c" providerId="ADAL" clId="{C625B387-BACC-4CDF-8090-556983D2B216}" dt="2026-10-08T14:26:03.191" v="18595" actId="478"/>
-          <ac:spMkLst>
-            <pc:docMk/>
-            <pc:sldMk cId="2528761859" sldId="256"/>
-            <ac:spMk id="7" creationId="{FB688922-1439-800C-86AE-CAE2FD89E003}"/>
-          </ac:spMkLst>
-        </pc:spChg>
-        <pc:spChg chg="add mod">
-          <ac:chgData name="Katenkamp, Dani" userId="3c420122-3701-45c6-afcd-a2335153bc7c" providerId="ADAL" clId="{C625B387-BACC-4CDF-8090-556983D2B216}" dt="2026-10-08T14:33:54.186" v="18775" actId="1037"/>
+          <ac:chgData name="Katenkamp, Dani" userId="3c420122-3701-45c6-afcd-a2335153bc7c" providerId="ADAL" clId="{C625B387-BACC-4CDF-8090-556983D2B216}" dt="2026-10-16T19:22:38.433" v="18777" actId="478"/>
           <ac:spMkLst>
             <pc:docMk/>
             <pc:sldMk cId="2528761859" sldId="256"/>
             <ac:spMk id="10" creationId="{078330A7-0AAB-D650-210E-8A45C73CF6FC}"/>
           </ac:spMkLst>
         </pc:spChg>
-        <pc:picChg chg="add mod">
-          <ac:chgData name="Katenkamp, Dani" userId="3c420122-3701-45c6-afcd-a2335153bc7c" providerId="ADAL" clId="{C625B387-BACC-4CDF-8090-556983D2B216}" dt="2026-10-08T14:33:54.186" v="18775" actId="1037"/>
+        <pc:picChg chg="add del mod">
+          <ac:chgData name="Katenkamp, Dani" userId="3c420122-3701-45c6-afcd-a2335153bc7c" providerId="ADAL" clId="{C625B387-BACC-4CDF-8090-556983D2B216}" dt="2026-10-16T19:22:35.080" v="18776" actId="478"/>
           <ac:picMkLst>
             <pc:docMk/>
             <pc:sldMk cId="2528761859" sldId="256"/>
             <ac:picMk id="9" creationId="{85394FCD-1ED5-1E04-D28A-9618C984CC5B}"/>
           </ac:picMkLst>
         </pc:picChg>
-        <pc:cxnChg chg="add mod">
-          <ac:chgData name="Katenkamp, Dani" userId="3c420122-3701-45c6-afcd-a2335153bc7c" providerId="ADAL" clId="{C625B387-BACC-4CDF-8090-556983D2B216}" dt="2026-10-08T14:33:54.186" v="18775" actId="1037"/>
+        <pc:cxnChg chg="add del mod">
+          <ac:chgData name="Katenkamp, Dani" userId="3c420122-3701-45c6-afcd-a2335153bc7c" providerId="ADAL" clId="{C625B387-BACC-4CDF-8090-556983D2B216}" dt="2026-10-16T19:22:41.641" v="18778" actId="478"/>
           <ac:cxnSpMkLst>
             <pc:docMk/>
             <pc:sldMk cId="2528761859" sldId="256"/>
@@ -372,14 +340,6 @@
             <ac:spMk id="2" creationId="{7698ED58-A5DE-355E-0000-5C183EBB78BF}"/>
           </ac:spMkLst>
         </pc:spChg>
-        <pc:spChg chg="del mod">
-          <ac:chgData name="Katenkamp, Dani" userId="3c420122-3701-45c6-afcd-a2335153bc7c" providerId="ADAL" clId="{C625B387-BACC-4CDF-8090-556983D2B216}" dt="2026-10-07T23:31:51.702" v="13839" actId="478"/>
-          <ac:spMkLst>
-            <pc:docMk/>
-            <pc:sldMk cId="2372676427" sldId="259"/>
-            <ac:spMk id="6" creationId="{3F7B7E3B-CAA6-5060-C22E-C3F62E933A7D}"/>
-          </ac:spMkLst>
-        </pc:spChg>
         <pc:spChg chg="add mod">
           <ac:chgData name="Katenkamp, Dani" userId="3c420122-3701-45c6-afcd-a2335153bc7c" providerId="ADAL" clId="{C625B387-BACC-4CDF-8090-556983D2B216}" dt="2026-10-08T05:54:24.799" v="16960" actId="1076"/>
           <ac:spMkLst>
@@ -388,14 +348,6 @@
             <ac:spMk id="7" creationId="{F6277DB8-3C59-F6EF-927A-6F8163C1426A}"/>
           </ac:spMkLst>
         </pc:spChg>
-        <pc:graphicFrameChg chg="add del mod modGraphic">
-          <ac:chgData name="Katenkamp, Dani" userId="3c420122-3701-45c6-afcd-a2335153bc7c" providerId="ADAL" clId="{C625B387-BACC-4CDF-8090-556983D2B216}" dt="2026-10-07T23:32:41.884" v="13847" actId="478"/>
-          <ac:graphicFrameMkLst>
-            <pc:docMk/>
-            <pc:sldMk cId="2372676427" sldId="259"/>
-            <ac:graphicFrameMk id="3" creationId="{E2CC139F-DC3B-AB40-628E-8E7C6385E423}"/>
-          </ac:graphicFrameMkLst>
-        </pc:graphicFrameChg>
         <pc:graphicFrameChg chg="add mod modGraphic">
           <ac:chgData name="Katenkamp, Dani" userId="3c420122-3701-45c6-afcd-a2335153bc7c" providerId="ADAL" clId="{C625B387-BACC-4CDF-8090-556983D2B216}" dt="2026-10-08T05:47:33.329" v="16543" actId="20577"/>
           <ac:graphicFrameMkLst>
@@ -519,14 +471,6 @@
             <ac:spMk id="3" creationId="{61B282DE-347A-94C2-9465-D04A41AB1F23}"/>
           </ac:spMkLst>
         </pc:spChg>
-        <pc:spChg chg="add del mod">
-          <ac:chgData name="Katenkamp, Dani" userId="3c420122-3701-45c6-afcd-a2335153bc7c" providerId="ADAL" clId="{C625B387-BACC-4CDF-8090-556983D2B216}" dt="2026-10-07T14:30:27.361" v="13609" actId="21"/>
-          <ac:spMkLst>
-            <pc:docMk/>
-            <pc:sldMk cId="414177041" sldId="265"/>
-            <ac:spMk id="5" creationId="{9CA924E9-6894-96C0-2532-65FA20BDD6BD}"/>
-          </ac:spMkLst>
-        </pc:spChg>
         <pc:spChg chg="add mod">
           <ac:chgData name="Katenkamp, Dani" userId="3c420122-3701-45c6-afcd-a2335153bc7c" providerId="ADAL" clId="{C625B387-BACC-4CDF-8090-556983D2B216}" dt="2026-10-08T05:43:16.440" v="16365" actId="208"/>
           <ac:spMkLst>
@@ -556,14 +500,6 @@
             <pc:docMk/>
             <pc:sldMk cId="2764880259" sldId="266"/>
             <ac:spMk id="3" creationId="{C82AFA0A-B787-2D9C-F51C-6F7B5172726B}"/>
-          </ac:spMkLst>
-        </pc:spChg>
-        <pc:spChg chg="add del mod">
-          <ac:chgData name="Katenkamp, Dani" userId="3c420122-3701-45c6-afcd-a2335153bc7c" providerId="ADAL" clId="{C625B387-BACC-4CDF-8090-556983D2B216}" dt="2026-10-08T05:15:03.691" v="14050" actId="478"/>
-          <ac:spMkLst>
-            <pc:docMk/>
-            <pc:sldMk cId="2764880259" sldId="266"/>
-            <ac:spMk id="6" creationId="{11EAE1B6-BCE2-8C9F-E731-7B208F91497C}"/>
           </ac:spMkLst>
         </pc:spChg>
       </pc:sldChg>
@@ -1014,36 +950,12 @@
             <ac:spMk id="2" creationId="{0E493D0E-C38B-53CA-4EAB-3231762CB0D3}"/>
           </ac:spMkLst>
         </pc:spChg>
-        <pc:spChg chg="add del mod">
-          <ac:chgData name="Katenkamp, Dani" userId="3c420122-3701-45c6-afcd-a2335153bc7c" providerId="ADAL" clId="{C625B387-BACC-4CDF-8090-556983D2B216}" dt="2026-10-08T05:24:48.193" v="15359" actId="478"/>
-          <ac:spMkLst>
-            <pc:docMk/>
-            <pc:sldMk cId="4033809697" sldId="283"/>
-            <ac:spMk id="5" creationId="{0EC8E8B7-0F4A-BB1A-5B6A-6C75D1FB6848}"/>
-          </ac:spMkLst>
-        </pc:spChg>
-        <pc:spChg chg="add del mod">
-          <ac:chgData name="Katenkamp, Dani" userId="3c420122-3701-45c6-afcd-a2335153bc7c" providerId="ADAL" clId="{C625B387-BACC-4CDF-8090-556983D2B216}" dt="2026-10-08T05:24:45.649" v="15358" actId="478"/>
-          <ac:spMkLst>
-            <pc:docMk/>
-            <pc:sldMk cId="4033809697" sldId="283"/>
-            <ac:spMk id="6" creationId="{27E36D9E-4210-C8B2-48B0-856D8659AE64}"/>
-          </ac:spMkLst>
-        </pc:spChg>
         <pc:spChg chg="add mod">
           <ac:chgData name="Katenkamp, Dani" userId="3c420122-3701-45c6-afcd-a2335153bc7c" providerId="ADAL" clId="{C625B387-BACC-4CDF-8090-556983D2B216}" dt="2026-10-08T05:26:41.137" v="15625" actId="1076"/>
           <ac:spMkLst>
             <pc:docMk/>
             <pc:sldMk cId="4033809697" sldId="283"/>
             <ac:spMk id="7" creationId="{E4F9B629-D22B-025F-D4C4-9445ED81F008}"/>
-          </ac:spMkLst>
-        </pc:spChg>
-        <pc:spChg chg="add del mod">
-          <ac:chgData name="Katenkamp, Dani" userId="3c420122-3701-45c6-afcd-a2335153bc7c" providerId="ADAL" clId="{C625B387-BACC-4CDF-8090-556983D2B216}" dt="2026-10-08T05:47:22.199" v="16542" actId="478"/>
-          <ac:spMkLst>
-            <pc:docMk/>
-            <pc:sldMk cId="4033809697" sldId="283"/>
-            <ac:spMk id="8" creationId="{54405E9C-131B-758C-D10B-DDD12EDD5D4B}"/>
           </ac:spMkLst>
         </pc:spChg>
         <pc:graphicFrameChg chg="add mod modGraphic">
@@ -6501,7 +6413,7 @@
           <a:p>
             <a:fld id="{4A714D01-3C37-4BD9-88C6-8707F0A7850C}" type="datetimeFigureOut">
               <a:rPr lang="en-US" smtClean="0"/>
-              <a:t>10/8/2026</a:t>
+              <a:t>10/16/2026</a:t>
             </a:fld>
             <a:endParaRPr lang="en-US"/>
           </a:p>
@@ -7842,7 +7754,7 @@
           <a:p>
             <a:fld id="{22B5FCA0-DF4B-4CBC-9339-14A7486DB0A3}" type="datetime1">
               <a:rPr lang="en-US" smtClean="0"/>
-              <a:t>10/8/2026</a:t>
+              <a:t>10/16/2026</a:t>
             </a:fld>
             <a:endParaRPr lang="en-US"/>
           </a:p>
@@ -8040,7 +7952,7 @@
           <a:p>
             <a:fld id="{7152DEE1-B746-48B4-8783-824E92D74026}" type="datetime1">
               <a:rPr lang="en-US" smtClean="0"/>
-              <a:t>10/8/2026</a:t>
+              <a:t>10/16/2026</a:t>
             </a:fld>
             <a:endParaRPr lang="en-US"/>
           </a:p>
@@ -8248,7 +8160,7 @@
           <a:p>
             <a:fld id="{67D9ACCD-9BE0-4D42-BF7A-367739AE3912}" type="datetime1">
               <a:rPr lang="en-US" smtClean="0"/>
-              <a:t>10/8/2026</a:t>
+              <a:t>10/16/2026</a:t>
             </a:fld>
             <a:endParaRPr lang="en-US"/>
           </a:p>
@@ -8446,7 +8358,7 @@
           <a:p>
             <a:fld id="{01522DE0-1E50-4AB5-B876-59C640A71459}" type="datetime1">
               <a:rPr lang="en-US" smtClean="0"/>
-              <a:t>10/8/2026</a:t>
+              <a:t>10/16/2026</a:t>
             </a:fld>
             <a:endParaRPr lang="en-US"/>
           </a:p>
@@ -8721,7 +8633,7 @@
           <a:p>
             <a:fld id="{2BC0C795-6481-4484-A5F0-49304DFAEFB2}" type="datetime1">
               <a:rPr lang="en-US" smtClean="0"/>
-              <a:t>10/8/2026</a:t>
+              <a:t>10/16/2026</a:t>
             </a:fld>
             <a:endParaRPr lang="en-US"/>
           </a:p>
@@ -8986,7 +8898,7 @@
           <a:p>
             <a:fld id="{EA9F47BC-9884-4FEB-AD70-6FD97D2C433E}" type="datetime1">
               <a:rPr lang="en-US" smtClean="0"/>
-              <a:t>10/8/2026</a:t>
+              <a:t>10/16/2026</a:t>
             </a:fld>
             <a:endParaRPr lang="en-US"/>
           </a:p>
@@ -9398,7 +9310,7 @@
           <a:p>
             <a:fld id="{DD0D35B2-4EEC-4D85-B3B6-0D2BDF5AA778}" type="datetime1">
               <a:rPr lang="en-US" smtClean="0"/>
-              <a:t>10/8/2026</a:t>
+              <a:t>10/16/2026</a:t>
             </a:fld>
             <a:endParaRPr lang="en-US"/>
           </a:p>
@@ -9539,7 +9451,7 @@
           <a:p>
             <a:fld id="{069BAA0D-E528-4B82-9EE6-E3C7F421BAFD}" type="datetime1">
               <a:rPr lang="en-US" smtClean="0"/>
-              <a:t>10/8/2026</a:t>
+              <a:t>10/16/2026</a:t>
             </a:fld>
             <a:endParaRPr lang="en-US"/>
           </a:p>
@@ -9652,7 +9564,7 @@
           <a:p>
             <a:fld id="{5612D302-4D73-4717-B7A5-022A4D51D079}" type="datetime1">
               <a:rPr lang="en-US" smtClean="0"/>
-              <a:t>10/8/2026</a:t>
+              <a:t>10/16/2026</a:t>
             </a:fld>
             <a:endParaRPr lang="en-US"/>
           </a:p>
@@ -9963,7 +9875,7 @@
           <a:p>
             <a:fld id="{2AEE5923-EFF8-47B7-8ADB-D32CCE6C2BF5}" type="datetime1">
               <a:rPr lang="en-US" smtClean="0"/>
-              <a:t>10/8/2026</a:t>
+              <a:t>10/16/2026</a:t>
             </a:fld>
             <a:endParaRPr lang="en-US"/>
           </a:p>
@@ -10251,7 +10163,7 @@
           <a:p>
             <a:fld id="{A950B4C7-B1E3-487B-A756-78DA8E48DD6A}" type="datetime1">
               <a:rPr lang="en-US" smtClean="0"/>
-              <a:t>10/8/2026</a:t>
+              <a:t>10/16/2026</a:t>
             </a:fld>
             <a:endParaRPr lang="en-US"/>
           </a:p>
@@ -10492,7 +10404,7 @@
           <a:p>
             <a:fld id="{5ED3448B-59CD-408E-955A-950B685E23AA}" type="datetime1">
               <a:rPr lang="en-US" smtClean="0"/>
-              <a:t>10/8/2026</a:t>
+              <a:t>10/16/2026</a:t>
             </a:fld>
             <a:endParaRPr lang="en-US"/>
           </a:p>
@@ -10982,135 +10894,6 @@
           </a:p>
         </p:txBody>
       </p:sp>
-      <p:pic>
-        <p:nvPicPr>
-          <p:cNvPr id="9" name="Picture 8">
-            <a:extLst>
-              <a:ext uri="{FF2B5EF4-FFF2-40B4-BE49-F238E27FC236}">
-                <a16:creationId xmlns:a16="http://schemas.microsoft.com/office/drawing/2014/main" id="{85394FCD-1ED5-1E04-D28A-9618C984CC5B}"/>
-              </a:ext>
-            </a:extLst>
-          </p:cNvPr>
-          <p:cNvPicPr>
-            <a:picLocks noChangeAspect="1"/>
-          </p:cNvPicPr>
-          <p:nvPr/>
-        </p:nvPicPr>
-        <p:blipFill>
-          <a:blip r:embed="rId2">
-            <a:extLst>
-              <a:ext uri="{28A0092B-C50C-407E-A947-70E740481C1C}">
-                <a14:useLocalDpi xmlns:a14="http://schemas.microsoft.com/office/drawing/2010/main" val="0"/>
-              </a:ext>
-            </a:extLst>
-          </a:blip>
-          <a:stretch>
-            <a:fillRect/>
-          </a:stretch>
-        </p:blipFill>
-        <p:spPr>
-          <a:xfrm>
-            <a:off x="9744075" y="4467225"/>
-            <a:ext cx="2019299" cy="2019299"/>
-          </a:xfrm>
-          <a:prstGeom prst="rect">
-            <a:avLst/>
-          </a:prstGeom>
-        </p:spPr>
-      </p:pic>
-      <p:sp>
-        <p:nvSpPr>
-          <p:cNvPr id="10" name="TextBox 9">
-            <a:extLst>
-              <a:ext uri="{FF2B5EF4-FFF2-40B4-BE49-F238E27FC236}">
-                <a16:creationId xmlns:a16="http://schemas.microsoft.com/office/drawing/2014/main" id="{078330A7-0AAB-D650-210E-8A45C73CF6FC}"/>
-              </a:ext>
-            </a:extLst>
-          </p:cNvPr>
-          <p:cNvSpPr txBox="1"/>
-          <p:nvPr/>
-        </p:nvSpPr>
-        <p:spPr>
-          <a:xfrm>
-            <a:off x="4867275" y="5184486"/>
-            <a:ext cx="4524375" cy="584775"/>
-          </a:xfrm>
-          <a:prstGeom prst="rect">
-            <a:avLst/>
-          </a:prstGeom>
-          <a:noFill/>
-        </p:spPr>
-        <p:txBody>
-          <a:bodyPr wrap="square" rtlCol="0">
-            <a:spAutoFit/>
-          </a:bodyPr>
-          <a:lstStyle/>
-          <a:p>
-            <a:r>
-              <a:rPr lang="en-US" sz="1600" dirty="0"/>
-              <a:t>QR code to my website and a copy of these slides</a:t>
-            </a:r>
-          </a:p>
-          <a:p>
-            <a:r>
-              <a:rPr lang="en-US" sz="1600" dirty="0"/>
-              <a:t>(alt. can find at </a:t>
-            </a:r>
-            <a:r>
-              <a:rPr lang="en-US" sz="1600" b="1" dirty="0"/>
-              <a:t>https://loblollylinguistics.com/</a:t>
-            </a:r>
-            <a:r>
-              <a:rPr lang="en-US" sz="1600" dirty="0"/>
-              <a:t>)</a:t>
-            </a:r>
-            <a:endParaRPr lang="en-US" sz="1600" b="1" dirty="0"/>
-          </a:p>
-        </p:txBody>
-      </p:sp>
-      <p:cxnSp>
-        <p:nvCxnSpPr>
-          <p:cNvPr id="12" name="Straight Arrow Connector 11">
-            <a:extLst>
-              <a:ext uri="{FF2B5EF4-FFF2-40B4-BE49-F238E27FC236}">
-                <a16:creationId xmlns:a16="http://schemas.microsoft.com/office/drawing/2014/main" id="{8CA9E4DE-D713-C460-311A-C4777A3FF8E2}"/>
-              </a:ext>
-            </a:extLst>
-          </p:cNvPr>
-          <p:cNvCxnSpPr>
-            <a:cxnSpLocks/>
-            <a:stCxn id="10" idx="3"/>
-            <a:endCxn id="9" idx="1"/>
-          </p:cNvCxnSpPr>
-          <p:nvPr/>
-        </p:nvCxnSpPr>
-        <p:spPr>
-          <a:xfrm>
-            <a:off x="9391650" y="5476874"/>
-            <a:ext cx="352425" cy="1"/>
-          </a:xfrm>
-          <a:prstGeom prst="straightConnector1">
-            <a:avLst/>
-          </a:prstGeom>
-          <a:ln>
-            <a:tailEnd type="triangle"/>
-          </a:ln>
-        </p:spPr>
-        <p:style>
-          <a:lnRef idx="2">
-            <a:schemeClr val="dk1"/>
-          </a:lnRef>
-          <a:fillRef idx="0">
-            <a:schemeClr val="dk1"/>
-          </a:fillRef>
-          <a:effectRef idx="1">
-            <a:schemeClr val="dk1"/>
-          </a:effectRef>
-          <a:fontRef idx="minor">
-            <a:schemeClr val="tx1"/>
-          </a:fontRef>
-        </p:style>
-      </p:cxnSp>
     </p:spTree>
     <p:extLst>
       <p:ext uri="{BB962C8B-B14F-4D97-AF65-F5344CB8AC3E}">

</xml_diff>